<commit_message>
Set the GLIDE number: EQ-2026-000146-COL
- meta.glide, the response-measures bullet (now tier: official, in all three
  languages) and the GLIDEnumber link label carry the assigned number.
- The overview slide uses a compact origin-time string; the localised long form
  had grown to three lines in Japanese and crowded the as-of note. The full
  local/UTC/JST times stay in the parameter table.
- qa_check.py: the placeholder check becomes a format check on the real number.

Co-Authored-By: Claude Opus 5 <noreply@anthropic.com>
Claude-Session: https://claude.ai/code/session_011nHxSkRE2cjkp1ba4m7SWZ
</commit_message>
<xml_diff>
--- a/reports/colombia_eq_20260810/output/ADRC_EQ_COL_Choco_20260810_EN.pptx
+++ b/reports/colombia_eq_20260810/output/ADRC_EQ_COL_Choco_20260810_EN.pptx
@@ -3379,7 +3379,7 @@
                 <a:ea typeface="Calibri" pitchFamily="34" charset="-122"/>
                 <a:cs typeface="Calibri" pitchFamily="34" charset="-120"/>
               </a:rPr>
-              <a:t>Mww 7.4   ·   depth 107 km   ·   MMI VII (Very strong) - USGS ShakeMap   ·   GLIDE EQ-2026-XXXXXX-COL (TBC)</a:t>
+              <a:t>Mww 7.4   ·   depth 107 km   ·   MMI VII (Very strong) - USGS ShakeMap   ·   GLIDE EQ-2026-000146-COL</a:t>
             </a:r>
             <a:endParaRPr lang="en-US" sz="1150" dirty="0"/>
           </a:p>
@@ -25337,7 +25337,7 @@
                           <a:ea typeface="Calibri" pitchFamily="34" charset="-122"/>
                           <a:cs typeface="Calibri" pitchFamily="34" charset="-120"/>
                         </a:rPr>
-                        <a:t>GLIDEnumber (for the event identifier once issued)</a:t>
+                        <a:t>GLIDEnumber — EQ-2026-000146-COL (event identifier)</a:t>
                       </a:r>
                       <a:endParaRPr lang="en-US" sz="950" dirty="0">
                         <a:latin typeface="Calibri" charset="0"/>
@@ -26281,8 +26281,8 @@
         </p:nvSpPr>
         <p:spPr>
           <a:xfrm>
-            <a:off x="365760" y="969264"/>
-            <a:ext cx="11430000" cy="329184"/>
+            <a:off x="365760" y="950976"/>
+            <a:ext cx="11430000" cy="384048"/>
           </a:xfrm>
           <a:prstGeom prst="rect">
             <a:avLst/>
@@ -26306,7 +26306,7 @@
                 <a:ea typeface="Calibri" pitchFamily="34" charset="-122"/>
                 <a:cs typeface="Calibri" pitchFamily="34" charset="-120"/>
               </a:rPr>
-              <a:t>10 Aug 2026, 07:34 COT (UTC-5)  (10 Aug 2026, 12:34 UTC / 10 Aug 2026, 21:34 JST)    |    Mww 7.4    |    depth 107 km    |    MMI VII (Very strong) - USGS ShakeMap</a:t>
+              <a:t>10 Aug 2026, 07:34 COT (12:34 UTC / 21:34 JST)    |    Mww 7.4    |    depth 107 km    |    MMI VII (Very strong) - USGS ShakeMap</a:t>
             </a:r>
             <a:endParaRPr lang="en-US" sz="1150" dirty="0"/>
           </a:p>
@@ -26320,7 +26320,7 @@
         </p:nvSpPr>
         <p:spPr>
           <a:xfrm>
-            <a:off x="365760" y="1280160"/>
+            <a:off x="365760" y="1335024"/>
             <a:ext cx="11430000" cy="274320"/>
           </a:xfrm>
           <a:prstGeom prst="rect">
@@ -26359,8 +26359,8 @@
         </p:nvSpPr>
         <p:spPr>
           <a:xfrm>
-            <a:off x="365760" y="1627632"/>
-            <a:ext cx="11430000" cy="4480560"/>
+            <a:off x="365760" y="1664208"/>
+            <a:ext cx="11430000" cy="4443984"/>
           </a:xfrm>
           <a:prstGeom prst="rect">
             <a:avLst/>
@@ -26624,13 +26624,13 @@
             <a:r>
               <a:rPr lang="en-US" sz="1250" b="1" dirty="0">
                 <a:solidFill>
-                  <a:srgbClr val="888888"/>
+                  <a:srgbClr val="1E7A34"/>
                 </a:solidFill>
                 <a:latin typeface="Calibri" pitchFamily="34" charset="0"/>
                 <a:ea typeface="Calibri" pitchFamily="34" charset="-122"/>
                 <a:cs typeface="Calibri" pitchFamily="34" charset="-120"/>
               </a:rPr>
-              <a:t>[TBC] </a:t>
+              <a:t>[Official] </a:t>
             </a:r>
             <a:pPr algn="l" indent="0" marL="0">
               <a:spcAft>
@@ -26647,7 +26647,7 @@
                 <a:ea typeface="Calibri" pitchFamily="34" charset="-122"/>
                 <a:cs typeface="Calibri" pitchFamily="34" charset="-120"/>
               </a:rPr>
-              <a:t>A GLIDE number for this event had not been confirmed at the time of writing; it will be added once issued.</a:t>
+              <a:t>GLIDE number assigned for this event: EQ-2026-000146-COL.</a:t>
             </a:r>
             <a:endParaRPr lang="en-US" sz="1250" dirty="0"/>
           </a:p>
@@ -35954,7 +35954,7 @@
                           <a:ea typeface="Calibri" pitchFamily="34" charset="-122"/>
                           <a:cs typeface="Calibri" pitchFamily="34" charset="-120"/>
                         </a:rPr>
-                        <a:t>EQ-2026-XXXXXX-COL (TBC)</a:t>
+                        <a:t>EQ-2026-000146-COL</a:t>
                       </a:r>
                       <a:endParaRPr lang="en-US" sz="950" dirty="0">
                         <a:latin typeface="Calibri" charset="0"/>

</xml_diff>

<commit_message>
Record the Copernicus activation correctly; EMSR915 is not this event
EMSR915 is a wildfire activation in Mallakaster, Albania (activated
10/08/2026 07:38 UTC, five hours before this earthquake), so it is not cited
as a source for the Colombia earthquake.

- The Copernicus item now records what is actually supported: the European
  Commission announced the activation of Copernicus for the earthquake
  (von der Leyen statement); the EMSR number is still unidentified, and the
  slide says so explicitly, including that EMSR915 belongs to another event.
- Satellite table statuses become "announced / number pending" and
  "reported / number pending", translated in all three languages.
- Removed a duplicated pair of UI_ES keys introduced by an earlier patch.

Co-Authored-By: Claude Opus 5 <noreply@anthropic.com>
Claude-Session: https://claude.ai/code/session_011nHxSkRE2cjkp1ba4m7SWZ
</commit_message>
<xml_diff>
--- a/reports/colombia_eq_20260810/output/ADRC_EQ_COL_Choco_20260810_EN.pptx
+++ b/reports/colombia_eq_20260810/output/ADRC_EQ_COL_Choco_20260810_EN.pptx
@@ -27,9 +27,10 @@
     <p:sldId id="275" r:id="rId21"/>
     <p:sldId id="276" r:id="rId22"/>
     <p:sldId id="277" r:id="rId23"/>
+    <p:sldId id="278" r:id="rId24"/>
   </p:sldIdLst>
   <p:notesMasterIdLst>
-    <p:notesMasterId r:id="rId24"/>
+    <p:notesMasterId r:id="rId25"/>
   </p:notesMasterIdLst>
   <p:sldSz cx="12192000" cy="6858000"/>
   <p:notesSz cx="6858000" cy="12192000"/>
@@ -2347,6 +2348,94 @@
 </p:notes>
 </file>
 
+<file path=ppt/notesSlides/notesSlide23.xml><?xml version="1.0" encoding="utf-8"?>
+<p:notes xmlns:a="http://schemas.openxmlformats.org/drawingml/2006/main" xmlns:r="http://schemas.openxmlformats.org/officeDocument/2006/relationships" xmlns:p="http://schemas.openxmlformats.org/presentationml/2006/main">
+  <p:cSld>
+    <p:spTree>
+      <p:nvGrpSpPr>
+        <p:cNvPr id="1" name=""/>
+        <p:cNvGrpSpPr/>
+        <p:nvPr/>
+      </p:nvGrpSpPr>
+      <p:grpSpPr>
+        <a:xfrm>
+          <a:off x="0" y="0"/>
+          <a:ext cx="0" cy="0"/>
+          <a:chOff x="0" y="0"/>
+          <a:chExt cx="0" cy="0"/>
+        </a:xfrm>
+      </p:grpSpPr>
+      <p:sp>
+        <p:nvSpPr>
+          <p:cNvPr id="2" name="Slide Image Placeholder 1"/>
+          <p:cNvSpPr>
+            <a:spLocks noGrp="1" noRot="1" noChangeAspect="1"/>
+          </p:cNvSpPr>
+          <p:nvPr>
+            <p:ph type="sldImg"/>
+          </p:nvPr>
+        </p:nvSpPr>
+        <p:spPr/>
+      </p:sp>
+      <p:sp>
+        <p:nvSpPr>
+          <p:cNvPr id="3" name="Notes Placeholder 2"/>
+          <p:cNvSpPr>
+            <a:spLocks noGrp="1"/>
+          </p:cNvSpPr>
+          <p:nvPr>
+            <p:ph type="body" idx="1"/>
+          </p:nvPr>
+        </p:nvSpPr>
+        <p:spPr/>
+        <p:txBody>
+          <a:bodyPr/>
+          <a:lstStyle/>
+          <a:p>
+            <a:r>
+              <a:rPr lang="en-US" dirty="0"/>
+              <a:t/>
+            </a:r>
+            <a:endParaRPr lang="en-US" dirty="0"/>
+          </a:p>
+        </p:txBody>
+      </p:sp>
+      <p:sp>
+        <p:nvSpPr>
+          <p:cNvPr id="4" name="Slide Number Placeholder 3"/>
+          <p:cNvSpPr>
+            <a:spLocks noGrp="1"/>
+          </p:cNvSpPr>
+          <p:nvPr>
+            <p:ph type="sldNum" sz="quarter" idx="10"/>
+          </p:nvPr>
+        </p:nvSpPr>
+        <p:spPr/>
+        <p:txBody>
+          <a:bodyPr/>
+          <a:lstStyle/>
+          <a:p>
+            <a:fld id="{F7021451-1387-4CA6-816F-3879F97B5CBC}" type="slidenum">
+              <a:rPr lang="en-US"/>
+              <a:t>23</a:t>
+            </a:fld>
+            <a:endParaRPr lang="en-US"/>
+          </a:p>
+        </p:txBody>
+      </p:sp>
+    </p:spTree>
+    <p:extLst>
+      <p:ext uri="{BB962C8B-B14F-4D97-AF65-F5344CB8AC3E}">
+        <p14:creationId xmlns:p14="http://schemas.microsoft.com/office/powerpoint/2010/main" val="1024086991"/>
+      </p:ext>
+    </p:extLst>
+  </p:cSld>
+  <p:clrMapOvr>
+    <a:masterClrMapping/>
+  </p:clrMapOvr>
+</p:notes>
+</file>
+
 <file path=ppt/notesSlides/notesSlide3.xml><?xml version="1.0" encoding="utf-8"?>
 <p:notes xmlns:a="http://schemas.openxmlformats.org/drawingml/2006/main" xmlns:r="http://schemas.openxmlformats.org/officeDocument/2006/relationships" xmlns:p="http://schemas.openxmlformats.org/presentationml/2006/main">
   <p:cSld>
@@ -12442,13 +12531,13 @@
             <a:r>
               <a:rPr lang="en-US" sz="1200" b="1" dirty="0">
                 <a:solidFill>
-                  <a:srgbClr val="888888"/>
+                  <a:srgbClr val="B8860B"/>
                 </a:solidFill>
                 <a:latin typeface="Calibri" pitchFamily="34" charset="0"/>
                 <a:ea typeface="Calibri" pitchFamily="34" charset="-122"/>
                 <a:cs typeface="Calibri" pitchFamily="34" charset="-120"/>
               </a:rPr>
-              <a:t>[TBC] </a:t>
+              <a:t>[Media] </a:t>
             </a:r>
             <a:pPr algn="l" indent="0" marL="0">
               <a:spcAft>
@@ -12465,7 +12554,7 @@
                 <a:ea typeface="Calibri" pitchFamily="34" charset="-122"/>
                 <a:cs typeface="Calibri" pitchFamily="34" charset="-120"/>
               </a:rPr>
-              <a:t>The International Charter 'Space and Major Disasters' is reported to have been activated for this earthquake, and the Copernicus Emergency Management Service mobilised, to provide satellite imagery for damage assessment. Activation numbers and value-added products are being confirmed.</a:t>
+              <a:t>The European Commission announced the activation of Copernicus for the earthquake (statement by President von der Leyen expressing EU support for Colombia). The International Charter 'Space and Major Disasters' is also reported to have been activated. Neither the Copernicus EMSR activation number nor the Charter activation number had been identified at the time of writing; note that EMSR915 belongs to a wildfire activation in Albania, not to this event.</a:t>
             </a:r>
             <a:endParaRPr lang="en-US" sz="1200" dirty="0"/>
           </a:p>
@@ -13408,7 +13497,7 @@
                           <a:ea typeface="Calibri" pitchFamily="34" charset="-122"/>
                           <a:cs typeface="Calibri" pitchFamily="34" charset="-120"/>
                         </a:rPr>
-                        <a:t>Reported / confirming</a:t>
+                        <a:t>Reported / number pending</a:t>
                       </a:r>
                       <a:endParaRPr lang="en-US" sz="900" dirty="0">
                         <a:latin typeface="Calibri" charset="0"/>
@@ -13614,7 +13703,7 @@
                           <a:ea typeface="Calibri" pitchFamily="34" charset="-122"/>
                           <a:cs typeface="Calibri" pitchFamily="34" charset="-120"/>
                         </a:rPr>
-                        <a:t>Rapid Mapping mobilised for the affected departments</a:t>
+                        <a:t>Rapid Mapping activation announced by the European Commission; EMSR activation number not yet identified</a:t>
                       </a:r>
                       <a:endParaRPr lang="en-US" sz="950" dirty="0">
                         <a:latin typeface="Calibri" charset="0"/>
@@ -13682,7 +13771,7 @@
                           <a:ea typeface="Calibri" pitchFamily="34" charset="-122"/>
                           <a:cs typeface="Calibri" pitchFamily="34" charset="-120"/>
                         </a:rPr>
-                        <a:t>Reported / confirming</a:t>
+                        <a:t>Announced / number pending</a:t>
                       </a:r>
                       <a:endParaRPr lang="en-US" sz="900" dirty="0">
                         <a:latin typeface="Calibri" charset="0"/>
@@ -13744,13 +13833,13 @@
                       <a:r>
                         <a:rPr lang="en-US" sz="850" b="1" dirty="0">
                           <a:solidFill>
-                            <a:srgbClr val="888888"/>
+                            <a:srgbClr val="B8860B"/>
                           </a:solidFill>
                           <a:latin typeface="Calibri" pitchFamily="34" charset="0"/>
                           <a:ea typeface="Calibri" pitchFamily="34" charset="-122"/>
                           <a:cs typeface="Calibri" pitchFamily="34" charset="-120"/>
                         </a:rPr>
-                        <a:t>TBC</a:t>
+                        <a:t>Media</a:t>
                       </a:r>
                       <a:endParaRPr lang="en-US" sz="850" dirty="0">
                         <a:latin typeface="Calibri" charset="0"/>
@@ -21150,7 +21239,7 @@
                 <a:ea typeface="Cambria" pitchFamily="34" charset="-122"/>
                 <a:cs typeface="Cambria" pitchFamily="34" charset="-120"/>
               </a:rPr>
-              <a:t>Useful Links &amp; Sources (1/2)</a:t>
+              <a:t>Useful Links &amp; Sources (1/3)</a:t>
             </a:r>
             <a:endParaRPr lang="en-US" sz="2100" dirty="0"/>
           </a:p>
@@ -24835,7 +24924,7 @@
                 <a:ea typeface="Cambria" pitchFamily="34" charset="-122"/>
                 <a:cs typeface="Cambria" pitchFamily="34" charset="-120"/>
               </a:rPr>
-              <a:t>Useful Links &amp; Sources (2/2)</a:t>
+              <a:t>Useful Links &amp; Sources (2/3)</a:t>
             </a:r>
             <a:endParaRPr lang="en-US" sz="2100" dirty="0"/>
           </a:p>
@@ -28411,6 +28500,656 @@
 <file path=ppt/slides/slide22.xml><?xml version="1.0" encoding="utf-8"?>
 <p:sld xmlns:a="http://schemas.openxmlformats.org/drawingml/2006/main" xmlns:r="http://schemas.openxmlformats.org/officeDocument/2006/relationships" xmlns:p="http://schemas.openxmlformats.org/presentationml/2006/main">
   <p:cSld name="Slide 22">
+    <p:bg>
+      <p:bgPr>
+        <a:solidFill>
+          <a:srgbClr val="FFFFFF"/>
+        </a:solidFill>
+      </p:bgPr>
+    </p:bg>
+    <p:spTree>
+      <p:nvGrpSpPr>
+        <p:cNvPr id="1" name=""/>
+        <p:cNvGrpSpPr/>
+        <p:nvPr/>
+      </p:nvGrpSpPr>
+      <p:grpSpPr>
+        <a:xfrm>
+          <a:off x="0" y="0"/>
+          <a:ext cx="0" cy="0"/>
+          <a:chOff x="0" y="0"/>
+          <a:chExt cx="0" cy="0"/>
+        </a:xfrm>
+      </p:grpSpPr>
+      <p:sp>
+        <p:nvSpPr>
+          <p:cNvPr id="2" name="Text 0"/>
+          <p:cNvSpPr/>
+          <p:nvPr/>
+        </p:nvSpPr>
+        <p:spPr>
+          <a:xfrm>
+            <a:off x="365760" y="292608"/>
+            <a:ext cx="10332720" cy="566928"/>
+          </a:xfrm>
+          <a:prstGeom prst="rect">
+            <a:avLst/>
+          </a:prstGeom>
+          <a:noFill/>
+          <a:ln/>
+        </p:spPr>
+        <p:txBody>
+          <a:bodyPr wrap="none" lIns="0" tIns="0" rIns="0" bIns="0" rtlCol="0" anchor="ctr">
+            <a:normAutofit/>
+          </a:bodyPr>
+          <a:lstStyle/>
+          <a:p>
+            <a:pPr algn="l" indent="0" marL="0">
+              <a:buNone/>
+            </a:pPr>
+            <a:r>
+              <a:rPr lang="en-US" sz="2100" b="1" dirty="0">
+                <a:solidFill>
+                  <a:srgbClr val="1F3864"/>
+                </a:solidFill>
+                <a:latin typeface="Cambria" pitchFamily="34" charset="0"/>
+                <a:ea typeface="Cambria" pitchFamily="34" charset="-122"/>
+                <a:cs typeface="Cambria" pitchFamily="34" charset="-120"/>
+              </a:rPr>
+              <a:t>Useful Links &amp; Sources (3/3)</a:t>
+            </a:r>
+            <a:endParaRPr lang="en-US" sz="2100" dirty="0"/>
+          </a:p>
+        </p:txBody>
+      </p:sp>
+      <p:pic>
+        <p:nvPicPr>
+          <p:cNvPr id="3" name="Image 0" descr="/home/user/whatsmap/reports/colombia_eq_20260810/images/adrc_logo.png">    </p:cNvPr>
+          <p:cNvPicPr>
+            <a:picLocks noChangeAspect="1"/>
+          </p:cNvPicPr>
+          <p:nvPr/>
+        </p:nvPicPr>
+        <p:blipFill>
+          <a:blip r:embed="rId1"/>
+          <a:stretch>
+            <a:fillRect/>
+          </a:stretch>
+        </p:blipFill>
+        <p:spPr>
+          <a:xfrm>
+            <a:off x="10945368" y="73152"/>
+            <a:ext cx="877824" cy="877824"/>
+          </a:xfrm>
+          <a:prstGeom prst="rect">
+            <a:avLst/>
+          </a:prstGeom>
+        </p:spPr>
+      </p:pic>
+      <p:graphicFrame>
+        <p:nvGraphicFramePr>
+          <p:cNvPr id="23" name="Table 0"/>
+          <p:cNvGraphicFramePr>
+            <a:graphicFrameLocks noGrp="1"/>
+          </p:cNvGraphicFramePr>
+          <p:nvPr>
+            <p:extLst>
+              <p:ext uri="{D42A27DB-BD31-4B8C-83A1-F6EECF244321}">
+                <p14:modId xmlns:p14="http://schemas.microsoft.com/office/powerpoint/2010/main" val="1579011935"/>
+              </p:ext>
+            </p:extLst>
+          </p:nvPr>
+        </p:nvGraphicFramePr>
+        <p:xfrm>
+          <a:off x="365760" y="1024128"/>
+          <a:ext cx="11430000" cy="914400"/>
+        </p:xfrm>
+        <a:graphic>
+          <a:graphicData uri="http://schemas.openxmlformats.org/drawingml/2006/table">
+            <a:tbl>
+              <a:tblPr/>
+              <a:tblGrid>
+                <a:gridCol w="4206240"/>
+                <a:gridCol w="822960"/>
+                <a:gridCol w="6400800"/>
+              </a:tblGrid>
+              <a:tr h="292608">
+                <a:tc>
+                  <a:txBody>
+                    <a:bodyPr/>
+                    <a:lstStyle/>
+                    <a:p>
+                      <a:pPr algn="l" indent="0" marL="0">
+                        <a:buNone/>
+                      </a:pPr>
+                      <a:r>
+                        <a:rPr lang="en-US" sz="1150" b="1" dirty="0">
+                          <a:solidFill>
+                            <a:srgbClr val="FFFFFF"/>
+                          </a:solidFill>
+                          <a:latin typeface="Calibri" pitchFamily="34" charset="0"/>
+                          <a:ea typeface="Calibri" pitchFamily="34" charset="-122"/>
+                          <a:cs typeface="Calibri" pitchFamily="34" charset="-120"/>
+                        </a:rPr>
+                        <a:t>Source</a:t>
+                      </a:r>
+                      <a:endParaRPr lang="en-US" sz="1150" dirty="0">
+                        <a:latin typeface="Calibri" charset="0"/>
+                        <a:ea typeface="Calibri" charset="0"/>
+                        <a:cs typeface="Calibri" charset="0"/>
+                      </a:endParaRPr>
+                    </a:p>
+                  </a:txBody>
+                  <a:tcPr marL="50800" marR="50800" marT="50800" marB="50800" anchor="ctr">
+                    <a:lnL w="6350" cap="flat" cmpd="sng" algn="ctr">
+                      <a:solidFill>
+                        <a:srgbClr val="D9D9D9"/>
+                      </a:solidFill>
+                      <a:prstDash val="solid"/>
+                      <a:round/>
+                      <a:headEnd type="none" w="med" len="med"/>
+                      <a:tailEnd type="none" w="med" len="med"/>
+                    </a:lnL>
+                    <a:lnR w="6350" cap="flat" cmpd="sng" algn="ctr">
+                      <a:solidFill>
+                        <a:srgbClr val="D9D9D9"/>
+                      </a:solidFill>
+                      <a:prstDash val="solid"/>
+                      <a:round/>
+                      <a:headEnd type="none" w="med" len="med"/>
+                      <a:tailEnd type="none" w="med" len="med"/>
+                    </a:lnR>
+                    <a:lnT w="6350" cap="flat" cmpd="sng" algn="ctr">
+                      <a:solidFill>
+                        <a:srgbClr val="D9D9D9"/>
+                      </a:solidFill>
+                      <a:prstDash val="solid"/>
+                      <a:round/>
+                      <a:headEnd type="none" w="med" len="med"/>
+                      <a:tailEnd type="none" w="med" len="med"/>
+                    </a:lnT>
+                    <a:lnB w="6350" cap="flat" cmpd="sng" algn="ctr">
+                      <a:solidFill>
+                        <a:srgbClr val="D9D9D9"/>
+                      </a:solidFill>
+                      <a:prstDash val="solid"/>
+                      <a:round/>
+                      <a:headEnd type="none" w="med" len="med"/>
+                      <a:tailEnd type="none" w="med" len="med"/>
+                    </a:lnB>
+                    <a:solidFill>
+                      <a:srgbClr val="1F3864"/>
+                    </a:solidFill>
+                  </a:tcPr>
+                </a:tc>
+                <a:tc>
+                  <a:txBody>
+                    <a:bodyPr/>
+                    <a:lstStyle/>
+                    <a:p>
+                      <a:pPr algn="l" indent="0" marL="0">
+                        <a:buNone/>
+                      </a:pPr>
+                      <a:r>
+                        <a:rPr lang="en-US" sz="1150" b="1" dirty="0">
+                          <a:solidFill>
+                            <a:srgbClr val="FFFFFF"/>
+                          </a:solidFill>
+                          <a:latin typeface="Calibri" pitchFamily="34" charset="0"/>
+                          <a:ea typeface="Calibri" pitchFamily="34" charset="-122"/>
+                          <a:cs typeface="Calibri" pitchFamily="34" charset="-120"/>
+                        </a:rPr>
+                        <a:t>Tier</a:t>
+                      </a:r>
+                      <a:endParaRPr lang="en-US" sz="1150" dirty="0">
+                        <a:latin typeface="Calibri" charset="0"/>
+                        <a:ea typeface="Calibri" charset="0"/>
+                        <a:cs typeface="Calibri" charset="0"/>
+                      </a:endParaRPr>
+                    </a:p>
+                  </a:txBody>
+                  <a:tcPr marL="50800" marR="50800" marT="50800" marB="50800" anchor="ctr">
+                    <a:lnL w="6350" cap="flat" cmpd="sng" algn="ctr">
+                      <a:solidFill>
+                        <a:srgbClr val="D9D9D9"/>
+                      </a:solidFill>
+                      <a:prstDash val="solid"/>
+                      <a:round/>
+                      <a:headEnd type="none" w="med" len="med"/>
+                      <a:tailEnd type="none" w="med" len="med"/>
+                    </a:lnL>
+                    <a:lnR w="6350" cap="flat" cmpd="sng" algn="ctr">
+                      <a:solidFill>
+                        <a:srgbClr val="D9D9D9"/>
+                      </a:solidFill>
+                      <a:prstDash val="solid"/>
+                      <a:round/>
+                      <a:headEnd type="none" w="med" len="med"/>
+                      <a:tailEnd type="none" w="med" len="med"/>
+                    </a:lnR>
+                    <a:lnT w="6350" cap="flat" cmpd="sng" algn="ctr">
+                      <a:solidFill>
+                        <a:srgbClr val="D9D9D9"/>
+                      </a:solidFill>
+                      <a:prstDash val="solid"/>
+                      <a:round/>
+                      <a:headEnd type="none" w="med" len="med"/>
+                      <a:tailEnd type="none" w="med" len="med"/>
+                    </a:lnT>
+                    <a:lnB w="6350" cap="flat" cmpd="sng" algn="ctr">
+                      <a:solidFill>
+                        <a:srgbClr val="D9D9D9"/>
+                      </a:solidFill>
+                      <a:prstDash val="solid"/>
+                      <a:round/>
+                      <a:headEnd type="none" w="med" len="med"/>
+                      <a:tailEnd type="none" w="med" len="med"/>
+                    </a:lnB>
+                    <a:solidFill>
+                      <a:srgbClr val="1F3864"/>
+                    </a:solidFill>
+                  </a:tcPr>
+                </a:tc>
+                <a:tc>
+                  <a:txBody>
+                    <a:bodyPr/>
+                    <a:lstStyle/>
+                    <a:p>
+                      <a:pPr algn="l" indent="0" marL="0">
+                        <a:buNone/>
+                      </a:pPr>
+                      <a:r>
+                        <a:rPr lang="en-US" sz="1150" b="1" dirty="0">
+                          <a:solidFill>
+                            <a:srgbClr val="FFFFFF"/>
+                          </a:solidFill>
+                          <a:latin typeface="Calibri" pitchFamily="34" charset="0"/>
+                          <a:ea typeface="Calibri" pitchFamily="34" charset="-122"/>
+                          <a:cs typeface="Calibri" pitchFamily="34" charset="-120"/>
+                        </a:rPr>
+                        <a:t>URL</a:t>
+                      </a:r>
+                      <a:endParaRPr lang="en-US" sz="1150" dirty="0">
+                        <a:latin typeface="Calibri" charset="0"/>
+                        <a:ea typeface="Calibri" charset="0"/>
+                        <a:cs typeface="Calibri" charset="0"/>
+                      </a:endParaRPr>
+                    </a:p>
+                  </a:txBody>
+                  <a:tcPr marL="50800" marR="50800" marT="50800" marB="50800" anchor="ctr">
+                    <a:lnL w="6350" cap="flat" cmpd="sng" algn="ctr">
+                      <a:solidFill>
+                        <a:srgbClr val="D9D9D9"/>
+                      </a:solidFill>
+                      <a:prstDash val="solid"/>
+                      <a:round/>
+                      <a:headEnd type="none" w="med" len="med"/>
+                      <a:tailEnd type="none" w="med" len="med"/>
+                    </a:lnL>
+                    <a:lnR w="6350" cap="flat" cmpd="sng" algn="ctr">
+                      <a:solidFill>
+                        <a:srgbClr val="D9D9D9"/>
+                      </a:solidFill>
+                      <a:prstDash val="solid"/>
+                      <a:round/>
+                      <a:headEnd type="none" w="med" len="med"/>
+                      <a:tailEnd type="none" w="med" len="med"/>
+                    </a:lnR>
+                    <a:lnT w="6350" cap="flat" cmpd="sng" algn="ctr">
+                      <a:solidFill>
+                        <a:srgbClr val="D9D9D9"/>
+                      </a:solidFill>
+                      <a:prstDash val="solid"/>
+                      <a:round/>
+                      <a:headEnd type="none" w="med" len="med"/>
+                      <a:tailEnd type="none" w="med" len="med"/>
+                    </a:lnT>
+                    <a:lnB w="6350" cap="flat" cmpd="sng" algn="ctr">
+                      <a:solidFill>
+                        <a:srgbClr val="D9D9D9"/>
+                      </a:solidFill>
+                      <a:prstDash val="solid"/>
+                      <a:round/>
+                      <a:headEnd type="none" w="med" len="med"/>
+                      <a:tailEnd type="none" w="med" len="med"/>
+                    </a:lnB>
+                    <a:solidFill>
+                      <a:srgbClr val="1F3864"/>
+                    </a:solidFill>
+                  </a:tcPr>
+                </a:tc>
+              </a:tr>
+              <a:tr h="292608">
+                <a:tc>
+                  <a:txBody>
+                    <a:bodyPr/>
+                    <a:lstStyle/>
+                    <a:p>
+                      <a:pPr algn="l" indent="0" marL="0">
+                        <a:buNone/>
+                      </a:pPr>
+                      <a:r>
+                        <a:rPr lang="en-US" sz="950" dirty="0">
+                          <a:solidFill>
+                            <a:srgbClr val="222222"/>
+                          </a:solidFill>
+                          <a:latin typeface="Calibri" pitchFamily="34" charset="0"/>
+                          <a:ea typeface="Calibri" pitchFamily="34" charset="-122"/>
+                          <a:cs typeface="Calibri" pitchFamily="34" charset="-120"/>
+                        </a:rPr>
+                        <a:t>European Commission — EU support for Colombia, Copernicus activated</a:t>
+                      </a:r>
+                      <a:endParaRPr lang="en-US" sz="950" dirty="0">
+                        <a:latin typeface="Calibri" charset="0"/>
+                        <a:ea typeface="Calibri" charset="0"/>
+                        <a:cs typeface="Calibri" charset="0"/>
+                      </a:endParaRPr>
+                    </a:p>
+                  </a:txBody>
+                  <a:tcPr marL="50800" marR="50800" marT="50800" marB="50800" anchor="ctr">
+                    <a:lnL w="6350" cap="flat" cmpd="sng" algn="ctr">
+                      <a:solidFill>
+                        <a:srgbClr val="D9D9D9"/>
+                      </a:solidFill>
+                      <a:prstDash val="solid"/>
+                      <a:round/>
+                      <a:headEnd type="none" w="med" len="med"/>
+                      <a:tailEnd type="none" w="med" len="med"/>
+                    </a:lnL>
+                    <a:lnR w="6350" cap="flat" cmpd="sng" algn="ctr">
+                      <a:solidFill>
+                        <a:srgbClr val="D9D9D9"/>
+                      </a:solidFill>
+                      <a:prstDash val="solid"/>
+                      <a:round/>
+                      <a:headEnd type="none" w="med" len="med"/>
+                      <a:tailEnd type="none" w="med" len="med"/>
+                    </a:lnR>
+                    <a:lnT w="6350" cap="flat" cmpd="sng" algn="ctr">
+                      <a:solidFill>
+                        <a:srgbClr val="D9D9D9"/>
+                      </a:solidFill>
+                      <a:prstDash val="solid"/>
+                      <a:round/>
+                      <a:headEnd type="none" w="med" len="med"/>
+                      <a:tailEnd type="none" w="med" len="med"/>
+                    </a:lnT>
+                    <a:lnB w="6350" cap="flat" cmpd="sng" algn="ctr">
+                      <a:solidFill>
+                        <a:srgbClr val="D9D9D9"/>
+                      </a:solidFill>
+                      <a:prstDash val="solid"/>
+                      <a:round/>
+                      <a:headEnd type="none" w="med" len="med"/>
+                      <a:tailEnd type="none" w="med" len="med"/>
+                    </a:lnB>
+                    <a:solidFill>
+                      <a:srgbClr val="EAF2F8"/>
+                    </a:solidFill>
+                  </a:tcPr>
+                </a:tc>
+                <a:tc>
+                  <a:txBody>
+                    <a:bodyPr/>
+                    <a:lstStyle/>
+                    <a:p>
+                      <a:pPr algn="ctr" indent="0" marL="0">
+                        <a:buNone/>
+                      </a:pPr>
+                      <a:r>
+                        <a:rPr lang="en-US" sz="850" b="1" dirty="0">
+                          <a:solidFill>
+                            <a:srgbClr val="B8860B"/>
+                          </a:solidFill>
+                          <a:latin typeface="Calibri" pitchFamily="34" charset="0"/>
+                          <a:ea typeface="Calibri" pitchFamily="34" charset="-122"/>
+                          <a:cs typeface="Calibri" pitchFamily="34" charset="-120"/>
+                        </a:rPr>
+                        <a:t>Media</a:t>
+                      </a:r>
+                      <a:endParaRPr lang="en-US" sz="850" dirty="0">
+                        <a:latin typeface="Calibri" charset="0"/>
+                        <a:ea typeface="Calibri" charset="0"/>
+                        <a:cs typeface="Calibri" charset="0"/>
+                      </a:endParaRPr>
+                    </a:p>
+                  </a:txBody>
+                  <a:tcPr marL="50800" marR="50800" marT="50800" marB="50800" anchor="ctr">
+                    <a:lnL w="6350" cap="flat" cmpd="sng" algn="ctr">
+                      <a:solidFill>
+                        <a:srgbClr val="D9D9D9"/>
+                      </a:solidFill>
+                      <a:prstDash val="solid"/>
+                      <a:round/>
+                      <a:headEnd type="none" w="med" len="med"/>
+                      <a:tailEnd type="none" w="med" len="med"/>
+                    </a:lnL>
+                    <a:lnR w="6350" cap="flat" cmpd="sng" algn="ctr">
+                      <a:solidFill>
+                        <a:srgbClr val="D9D9D9"/>
+                      </a:solidFill>
+                      <a:prstDash val="solid"/>
+                      <a:round/>
+                      <a:headEnd type="none" w="med" len="med"/>
+                      <a:tailEnd type="none" w="med" len="med"/>
+                    </a:lnR>
+                    <a:lnT w="6350" cap="flat" cmpd="sng" algn="ctr">
+                      <a:solidFill>
+                        <a:srgbClr val="D9D9D9"/>
+                      </a:solidFill>
+                      <a:prstDash val="solid"/>
+                      <a:round/>
+                      <a:headEnd type="none" w="med" len="med"/>
+                      <a:tailEnd type="none" w="med" len="med"/>
+                    </a:lnT>
+                    <a:lnB w="6350" cap="flat" cmpd="sng" algn="ctr">
+                      <a:solidFill>
+                        <a:srgbClr val="D9D9D9"/>
+                      </a:solidFill>
+                      <a:prstDash val="solid"/>
+                      <a:round/>
+                      <a:headEnd type="none" w="med" len="med"/>
+                      <a:tailEnd type="none" w="med" len="med"/>
+                    </a:lnB>
+                    <a:solidFill>
+                      <a:srgbClr val="EAF2F8"/>
+                    </a:solidFill>
+                  </a:tcPr>
+                </a:tc>
+                <a:tc>
+                  <a:txBody>
+                    <a:bodyPr/>
+                    <a:lstStyle/>
+                    <a:p>
+                      <a:pPr algn="l" indent="0" marL="0">
+                        <a:buNone/>
+                      </a:pPr>
+                      <a:r>
+                        <a:rPr lang="en-US" sz="800" u="sng" dirty="0">
+                          <a:solidFill>
+                            <a:srgbClr val="0563C1"/>
+                          </a:solidFill>
+                          <a:latin typeface="Calibri" pitchFamily="34" charset="0"/>
+                          <a:ea typeface="Calibri" pitchFamily="34" charset="-122"/>
+                          <a:cs typeface="Calibri" pitchFamily="34" charset="-120"/>
+                          <a:hlinkClick r:id="rId2" invalidUrl="" action="" tgtFrame="" tooltip="" history="1" highlightClick="0" endSnd="0">
+                            <a:extLst>
+                              <a:ext uri="{A12FA001-AC4F-418D-AE19-62706E023703}">
+                                <ahyp:hlinkClr xmlns:ahyp="http://schemas.microsoft.com/office/drawing/2018/hyperlinkcolor" val="tx"/>
+                              </a:ext>
+                            </a:extLst>
+                          </a:hlinkClick>
+                        </a:rPr>
+                        <a:t>https://www.democrata.es/en/international/von-der-leyen-expresses-the-eu-s-support-for-colombia-and-activates-copernicus-after-the-earthquake/</a:t>
+                      </a:r>
+                      <a:endParaRPr lang="en-US" sz="800" dirty="0">
+                        <a:latin typeface="Calibri" charset="0"/>
+                        <a:ea typeface="Calibri" charset="0"/>
+                        <a:cs typeface="Calibri" charset="0"/>
+                      </a:endParaRPr>
+                    </a:p>
+                  </a:txBody>
+                  <a:tcPr marL="50800" marR="50800" marT="50800" marB="50800" anchor="ctr">
+                    <a:lnL w="6350" cap="flat" cmpd="sng" algn="ctr">
+                      <a:solidFill>
+                        <a:srgbClr val="D9D9D9"/>
+                      </a:solidFill>
+                      <a:prstDash val="solid"/>
+                      <a:round/>
+                      <a:headEnd type="none" w="med" len="med"/>
+                      <a:tailEnd type="none" w="med" len="med"/>
+                    </a:lnL>
+                    <a:lnR w="6350" cap="flat" cmpd="sng" algn="ctr">
+                      <a:solidFill>
+                        <a:srgbClr val="D9D9D9"/>
+                      </a:solidFill>
+                      <a:prstDash val="solid"/>
+                      <a:round/>
+                      <a:headEnd type="none" w="med" len="med"/>
+                      <a:tailEnd type="none" w="med" len="med"/>
+                    </a:lnR>
+                    <a:lnT w="6350" cap="flat" cmpd="sng" algn="ctr">
+                      <a:solidFill>
+                        <a:srgbClr val="D9D9D9"/>
+                      </a:solidFill>
+                      <a:prstDash val="solid"/>
+                      <a:round/>
+                      <a:headEnd type="none" w="med" len="med"/>
+                      <a:tailEnd type="none" w="med" len="med"/>
+                    </a:lnT>
+                    <a:lnB w="6350" cap="flat" cmpd="sng" algn="ctr">
+                      <a:solidFill>
+                        <a:srgbClr val="D9D9D9"/>
+                      </a:solidFill>
+                      <a:prstDash val="solid"/>
+                      <a:round/>
+                      <a:headEnd type="none" w="med" len="med"/>
+                      <a:tailEnd type="none" w="med" len="med"/>
+                    </a:lnB>
+                    <a:solidFill>
+                      <a:srgbClr val="EAF2F8"/>
+                    </a:solidFill>
+                  </a:tcPr>
+                </a:tc>
+              </a:tr>
+            </a:tbl>
+          </a:graphicData>
+        </a:graphic>
+      </p:graphicFrame>
+      <p:sp>
+        <p:nvSpPr>
+          <p:cNvPr id="5" name="Shape 1"/>
+          <p:cNvSpPr/>
+          <p:nvPr/>
+        </p:nvSpPr>
+        <p:spPr>
+          <a:xfrm>
+            <a:off x="10268712" y="6510528"/>
+            <a:ext cx="1554480" cy="274320"/>
+          </a:xfrm>
+          <a:prstGeom prst="rect">
+            <a:avLst/>
+          </a:prstGeom>
+          <a:solidFill>
+            <a:srgbClr val="E8A317"/>
+          </a:solidFill>
+          <a:ln w="12700">
+            <a:solidFill>
+              <a:srgbClr val="E8A317"/>
+            </a:solidFill>
+            <a:prstDash val="solid"/>
+          </a:ln>
+        </p:spPr>
+      </p:sp>
+      <p:sp>
+        <p:nvSpPr>
+          <p:cNvPr id="6" name="Text 2"/>
+          <p:cNvSpPr/>
+          <p:nvPr/>
+        </p:nvSpPr>
+        <p:spPr>
+          <a:xfrm>
+            <a:off x="10268712" y="6510528"/>
+            <a:ext cx="1554480" cy="274320"/>
+          </a:xfrm>
+          <a:prstGeom prst="rect">
+            <a:avLst/>
+          </a:prstGeom>
+          <a:noFill/>
+          <a:ln/>
+        </p:spPr>
+        <p:txBody>
+          <a:bodyPr wrap="square" lIns="0" tIns="0" rIns="0" bIns="0" rtlCol="0" anchor="ctr"/>
+          <a:lstStyle/>
+          <a:p>
+            <a:pPr algn="ctr" indent="0" marL="0">
+              <a:buNone/>
+            </a:pPr>
+            <a:r>
+              <a:rPr lang="en-US" sz="950" b="1" dirty="0">
+                <a:solidFill>
+                  <a:srgbClr val="000000"/>
+                </a:solidFill>
+                <a:latin typeface="Calibri" pitchFamily="34" charset="0"/>
+                <a:ea typeface="Calibri" pitchFamily="34" charset="-122"/>
+                <a:cs typeface="Calibri" pitchFamily="34" charset="-120"/>
+              </a:rPr>
+              <a:t>ADRC  11/08/2026</a:t>
+            </a:r>
+            <a:endParaRPr lang="en-US" sz="950" dirty="0"/>
+          </a:p>
+        </p:txBody>
+      </p:sp>
+      <p:sp>
+        <p:nvSpPr>
+          <p:cNvPr id="7" name="Text 3"/>
+          <p:cNvSpPr/>
+          <p:nvPr/>
+        </p:nvSpPr>
+        <p:spPr>
+          <a:xfrm>
+            <a:off x="365760" y="6547104"/>
+            <a:ext cx="548640" cy="219456"/>
+          </a:xfrm>
+          <a:prstGeom prst="rect">
+            <a:avLst/>
+          </a:prstGeom>
+          <a:noFill/>
+          <a:ln/>
+        </p:spPr>
+        <p:txBody>
+          <a:bodyPr wrap="square" lIns="0" tIns="0" rIns="0" bIns="0" rtlCol="0" anchor="ctr"/>
+          <a:lstStyle/>
+          <a:p>
+            <a:pPr algn="l" indent="0" marL="0">
+              <a:buNone/>
+            </a:pPr>
+            <a:r>
+              <a:rPr lang="en-US" sz="900" dirty="0">
+                <a:solidFill>
+                  <a:srgbClr val="6A6A6A"/>
+                </a:solidFill>
+                <a:latin typeface="Calibri" pitchFamily="34" charset="0"/>
+                <a:ea typeface="Calibri" pitchFamily="34" charset="-122"/>
+                <a:cs typeface="Calibri" pitchFamily="34" charset="-120"/>
+              </a:rPr>
+              <a:t>22</a:t>
+            </a:r>
+            <a:endParaRPr lang="en-US" sz="900" dirty="0"/>
+          </a:p>
+        </p:txBody>
+      </p:sp>
+    </p:spTree>
+  </p:cSld>
+  <p:clrMapOvr>
+    <a:masterClrMapping/>
+  </p:clrMapOvr>
+</p:sld>
+</file>
+
+<file path=ppt/slides/slide23.xml><?xml version="1.0" encoding="utf-8"?>
+<p:sld xmlns:a="http://schemas.openxmlformats.org/drawingml/2006/main" xmlns:r="http://schemas.openxmlformats.org/officeDocument/2006/relationships" xmlns:p="http://schemas.openxmlformats.org/presentationml/2006/main">
+  <p:cSld name="Slide 23">
     <p:bg>
       <p:bgPr>
         <a:solidFill>
@@ -28718,7 +29457,7 @@
                 <a:ea typeface="Calibri" pitchFamily="34" charset="-122"/>
                 <a:cs typeface="Calibri" pitchFamily="34" charset="-120"/>
               </a:rPr>
-              <a:t>22</a:t>
+              <a:t>23</a:t>
             </a:r>
             <a:endParaRPr lang="en-US" sz="900" dirty="0"/>
           </a:p>

</xml_diff>

<commit_message>
Record the confirmed Copernicus activation EMSR916
EMSR916 "Earthquake in Colombia", activated 10 Aug 2026 17:13 UTC (12:13 COT)
at the request of EC Services / DG ECHO for earthquake damage assessment
mapping; ongoing, 3 AOIs and 3 products.

- The Copernicus item moves from media to official and carries the activation
  number, requesting party, time and outputs; the International Charter is
  split out as a separate item and stays tbc until its number is confirmed.
- Timeline gains the activation at 12:13 COT, ordered before the ~17:00
  national damage report.
- The Copernicus source link now points at the EMSR916 activation page.

Co-Authored-By: Claude Opus 5 <noreply@anthropic.com>
Claude-Session: https://claude.ai/code/session_011nHxSkRE2cjkp1ba4m7SWZ
</commit_message>
<xml_diff>
--- a/reports/colombia_eq_20260810/output/ADRC_EQ_COL_Choco_20260810_EN.pptx
+++ b/reports/colombia_eq_20260810/output/ADRC_EQ_COL_Choco_20260810_EN.pptx
@@ -12531,13 +12531,13 @@
             <a:r>
               <a:rPr lang="en-US" sz="1200" b="1" dirty="0">
                 <a:solidFill>
-                  <a:srgbClr val="B8860B"/>
+                  <a:srgbClr val="1E7A34"/>
                 </a:solidFill>
                 <a:latin typeface="Calibri" pitchFamily="34" charset="0"/>
                 <a:ea typeface="Calibri" pitchFamily="34" charset="-122"/>
                 <a:cs typeface="Calibri" pitchFamily="34" charset="-120"/>
               </a:rPr>
-              <a:t>[Media] </a:t>
+              <a:t>[Official] </a:t>
             </a:r>
             <a:pPr algn="l" indent="0" marL="0">
               <a:spcAft>
@@ -12554,7 +12554,42 @@
                 <a:ea typeface="Calibri" pitchFamily="34" charset="-122"/>
                 <a:cs typeface="Calibri" pitchFamily="34" charset="-120"/>
               </a:rPr>
-              <a:t>The European Commission announced the activation of Copernicus for the earthquake (statement by President von der Leyen expressing EU support for Colombia). The International Charter 'Space and Major Disasters' is also reported to have been activated. Neither the Copernicus EMSR activation number nor the Charter activation number had been identified at the time of writing; note that EMSR915 belongs to a wildfire activation in Albania, not to this event.</a:t>
+              <a:t>Copernicus EMS Rapid Mapping activated as EMSR916 'Earthquake in Colombia' at 17:13 UTC on 10 August (12:13 COT), requested by EC Services / DG ECHO, to provide earthquake damage assessment emergency mapping. Status ongoing, with 3 areas of interest and 3 products at the time of writing. The activation reason names Quibdó, Pereira, Manizales and Cali as cities with significant damage and collapsed buildings.</a:t>
+            </a:r>
+            <a:endParaRPr lang="en-US" sz="1200" dirty="0"/>
+          </a:p>
+          <a:p>
+            <a:pPr algn="l" marL="342900" indent="-342900">
+              <a:buSzPct val="100000"/>
+              <a:buChar char="•"/>
+            </a:pPr>
+            <a:r>
+              <a:rPr lang="en-US" sz="1200" b="1" dirty="0">
+                <a:solidFill>
+                  <a:srgbClr val="888888"/>
+                </a:solidFill>
+                <a:latin typeface="Calibri" pitchFamily="34" charset="0"/>
+                <a:ea typeface="Calibri" pitchFamily="34" charset="-122"/>
+                <a:cs typeface="Calibri" pitchFamily="34" charset="-120"/>
+              </a:rPr>
+              <a:t>[TBC] </a:t>
+            </a:r>
+            <a:pPr algn="l" indent="0" marL="0">
+              <a:spcAft>
+                <a:spcPts val="500"/>
+              </a:spcAft>
+              <a:buNone/>
+            </a:pPr>
+            <a:r>
+              <a:rPr lang="en-US" sz="1300" dirty="0">
+                <a:solidFill>
+                  <a:srgbClr val="222222"/>
+                </a:solidFill>
+                <a:latin typeface="Calibri" pitchFamily="34" charset="0"/>
+                <a:ea typeface="Calibri" pitchFamily="34" charset="-122"/>
+                <a:cs typeface="Calibri" pitchFamily="34" charset="-120"/>
+              </a:rPr>
+              <a:t>The International Charter 'Space and Major Disasters' is also reported to have been activated for this earthquake; the activation number had not been confirmed at the time of writing.</a:t>
             </a:r>
             <a:endParaRPr lang="en-US" sz="1200" dirty="0"/>
           </a:p>
@@ -12800,7 +12835,7 @@
                   </a:extLst>
                 </a:hlinkClick>
               </a:rPr>
-              <a:t>Copernicus EMS - Rapid Mapping activations</a:t>
+              <a:t>Copernicus EMS — EMSR916 'Earthquake in Colombia' (activation)</a:t>
             </a:r>
             <a:pPr algn="l" indent="0" marL="0">
               <a:buNone/>
@@ -13703,7 +13738,7 @@
                           <a:ea typeface="Calibri" pitchFamily="34" charset="-122"/>
                           <a:cs typeface="Calibri" pitchFamily="34" charset="-120"/>
                         </a:rPr>
-                        <a:t>Rapid Mapping activation announced by the European Commission; EMSR activation number not yet identified</a:t>
+                        <a:t>EMSR916 'Earthquake in Colombia' — Rapid Mapping for damage assessment; requested by EC Services / DG ECHO; 3 AOIs, 3 products</a:t>
                       </a:r>
                       <a:endParaRPr lang="en-US" sz="950" dirty="0">
                         <a:latin typeface="Calibri" charset="0"/>
@@ -13771,7 +13806,7 @@
                           <a:ea typeface="Calibri" pitchFamily="34" charset="-122"/>
                           <a:cs typeface="Calibri" pitchFamily="34" charset="-120"/>
                         </a:rPr>
-                        <a:t>Announced / number pending</a:t>
+                        <a:t>Ongoing (EMSR916)</a:t>
                       </a:r>
                       <a:endParaRPr lang="en-US" sz="900" dirty="0">
                         <a:latin typeface="Calibri" charset="0"/>
@@ -13833,13 +13868,13 @@
                       <a:r>
                         <a:rPr lang="en-US" sz="850" b="1" dirty="0">
                           <a:solidFill>
-                            <a:srgbClr val="B8860B"/>
+                            <a:srgbClr val="1E7A34"/>
                           </a:solidFill>
                           <a:latin typeface="Calibri" pitchFamily="34" charset="0"/>
                           <a:ea typeface="Calibri" pitchFamily="34" charset="-122"/>
                           <a:cs typeface="Calibri" pitchFamily="34" charset="-120"/>
                         </a:rPr>
-                        <a:t>Media</a:t>
+                        <a:t>Official</a:t>
                       </a:r>
                       <a:endParaRPr lang="en-US" sz="850" dirty="0">
                         <a:latin typeface="Calibri" charset="0"/>
@@ -15161,7 +15196,7 @@
                   </a:extLst>
                 </a:hlinkClick>
               </a:rPr>
-              <a:t>Copernicus EMS - Rapid Mapping activations</a:t>
+              <a:t>Copernicus EMS — EMSR916 'Earthquake in Colombia' (activation)</a:t>
             </a:r>
             <a:pPr algn="l" indent="0" marL="0">
               <a:buNone/>
@@ -23064,7 +23099,7 @@
                           <a:ea typeface="Calibri" pitchFamily="34" charset="-122"/>
                           <a:cs typeface="Calibri" pitchFamily="34" charset="-120"/>
                         </a:rPr>
-                        <a:t>Copernicus EMS - Rapid Mapping activations</a:t>
+                        <a:t>Copernicus EMS — EMSR916 'Earthquake in Colombia' (activation)</a:t>
                       </a:r>
                       <a:endParaRPr lang="en-US" sz="950" dirty="0">
                         <a:latin typeface="Calibri" charset="0"/>
@@ -23207,7 +23242,7 @@
                             </a:extLst>
                           </a:hlinkClick>
                         </a:rPr>
-                        <a:t>https://emergency.copernicus.eu/mapping/list-of-activations-rapid</a:t>
+                        <a:t>https://mapping.emergency.copernicus.eu/activations/EMSR916/</a:t>
                       </a:r>
                       <a:endParaRPr lang="en-US" sz="800" dirty="0">
                         <a:latin typeface="Calibri" charset="0"/>
@@ -33261,7 +33296,7 @@
                           <a:ea typeface="Calibri" pitchFamily="34" charset="-122"/>
                           <a:cs typeface="Calibri" pitchFamily="34" charset="-120"/>
                         </a:rPr>
-                        <a:t>Afternoon</a:t>
+                        <a:t>12:13</a:t>
                       </a:r>
                       <a:endParaRPr lang="en-US" sz="1000" dirty="0">
                         <a:latin typeface="Calibri" charset="0"/>
@@ -33329,7 +33364,7 @@
                           <a:ea typeface="Calibri" pitchFamily="34" charset="-122"/>
                           <a:cs typeface="Calibri" pitchFamily="34" charset="-120"/>
                         </a:rPr>
-                        <a:t>First national damage report: 111 deaths, 87 injured; 1,575 homes damaged, 37 destroyed, 61 buildings collapsed; 18 health facilities, 52 educational facilities, 17 community facilities, 18 major roads and 6 regional airports damaged.</a:t>
+                        <a:t>Copernicus EMS Rapid Mapping activated as EMSR916 (17:13 UTC), requested by EC Services / DG ECHO, for earthquake damage assessment mapping.</a:t>
                       </a:r>
                       <a:endParaRPr lang="en-US" sz="1000" dirty="0">
                         <a:latin typeface="Calibri" charset="0"/>
@@ -33397,7 +33432,7 @@
                           <a:ea typeface="Calibri" pitchFamily="34" charset="-122"/>
                           <a:cs typeface="Calibri" pitchFamily="34" charset="-120"/>
                         </a:rPr>
-                        <a:t>Presidency / UNGRD</a:t>
+                        <a:t>Copernicus EMS</a:t>
                       </a:r>
                       <a:endParaRPr lang="en-US" sz="850" dirty="0">
                         <a:latin typeface="Calibri" charset="0"/>
@@ -33535,7 +33570,7 @@
                           <a:ea typeface="Calibri" pitchFamily="34" charset="-122"/>
                           <a:cs typeface="Calibri" pitchFamily="34" charset="-120"/>
                         </a:rPr>
-                        <a:t>Ecuador mobilises a 47-person USAR team with canine units; Mexico and other governments offer assistance, to be channelled through the Foreign Ministry and UNGRD.</a:t>
+                        <a:t>First national damage report: 111 deaths, 87 injured; 1,575 homes damaged, 37 destroyed, 61 buildings collapsed; 18 health facilities, 52 educational facilities, 17 community facilities, 18 major roads and 6 regional airports damaged.</a:t>
                       </a:r>
                       <a:endParaRPr lang="en-US" sz="1000" dirty="0">
                         <a:latin typeface="Calibri" charset="0"/>
@@ -33597,13 +33632,13 @@
                       <a:r>
                         <a:rPr lang="en-US" sz="850" b="1" dirty="0">
                           <a:solidFill>
-                            <a:srgbClr val="B8860B"/>
+                            <a:srgbClr val="1E7A34"/>
                           </a:solidFill>
                           <a:latin typeface="Calibri" pitchFamily="34" charset="0"/>
                           <a:ea typeface="Calibri" pitchFamily="34" charset="-122"/>
                           <a:cs typeface="Calibri" pitchFamily="34" charset="-120"/>
                         </a:rPr>
-                        <a:t>International media</a:t>
+                        <a:t>Presidency / UNGRD</a:t>
                       </a:r>
                       <a:endParaRPr lang="en-US" sz="850" dirty="0">
                         <a:latin typeface="Calibri" charset="0"/>
@@ -33673,7 +33708,7 @@
                           <a:ea typeface="Calibri" pitchFamily="34" charset="-122"/>
                           <a:cs typeface="Calibri" pitchFamily="34" charset="-120"/>
                         </a:rPr>
-                        <a:t>Same day</a:t>
+                        <a:t>Afternoon</a:t>
                       </a:r>
                       <a:endParaRPr lang="en-US" sz="1000" dirty="0">
                         <a:latin typeface="Calibri" charset="0"/>
@@ -33741,7 +33776,7 @@
                           <a:ea typeface="Calibri" pitchFamily="34" charset="-122"/>
                           <a:cs typeface="Calibri" pitchFamily="34" charset="-120"/>
                         </a:rPr>
-                        <a:t>Activation of the International Charter 'Space and Major Disasters' and mobilisation of the Copernicus Emergency Management Service are reported; details being confirmed.</a:t>
+                        <a:t>Ecuador mobilises a 47-person USAR team with canine units; Mexico and other governments offer assistance, to be channelled through the Foreign Ministry and UNGRD.</a:t>
                       </a:r>
                       <a:endParaRPr lang="en-US" sz="1000" dirty="0">
                         <a:latin typeface="Calibri" charset="0"/>
@@ -33803,13 +33838,13 @@
                       <a:r>
                         <a:rPr lang="en-US" sz="850" b="1" dirty="0">
                           <a:solidFill>
-                            <a:srgbClr val="888888"/>
+                            <a:srgbClr val="B8860B"/>
                           </a:solidFill>
                           <a:latin typeface="Calibri" pitchFamily="34" charset="0"/>
                           <a:ea typeface="Calibri" pitchFamily="34" charset="-122"/>
                           <a:cs typeface="Calibri" pitchFamily="34" charset="-120"/>
                         </a:rPr>
-                        <a:t>Charter / Copernicus</a:t>
+                        <a:t>International media</a:t>
                       </a:r>
                       <a:endParaRPr lang="en-US" sz="850" dirty="0">
                         <a:latin typeface="Calibri" charset="0"/>

</xml_diff>